<commit_message>
Update Week 9 lecture slides
</commit_message>
<xml_diff>
--- a/files/inst414_spring2026/lectures/lecture_9b_gbdt.pptx
+++ b/files/inst414_spring2026/lectures/lecture_9b_gbdt.pptx
@@ -209,7 +209,7 @@
           <a:p>
             <a:fld id="{D104826B-A3D5-45F3-8F36-8A4F0179AFBF}" type="datetimeFigureOut">
               <a:rPr lang="en-US" smtClean="0"/>
-              <a:t>3/30/2026</a:t>
+              <a:t>3/31/2026</a:t>
             </a:fld>
             <a:endParaRPr lang="en-US"/>
           </a:p>
@@ -623,7 +623,7 @@
           <a:p>
             <a:fld id="{49B836C9-039A-46E3-8B8C-694019AC96F9}" type="datetimeFigureOut">
               <a:rPr lang="en-US" smtClean="0"/>
-              <a:t>3/30/2026</a:t>
+              <a:t>3/31/2026</a:t>
             </a:fld>
             <a:endParaRPr lang="en-US"/>
           </a:p>
@@ -821,7 +821,7 @@
           <a:p>
             <a:fld id="{49B836C9-039A-46E3-8B8C-694019AC96F9}" type="datetimeFigureOut">
               <a:rPr lang="en-US" smtClean="0"/>
-              <a:t>3/30/2026</a:t>
+              <a:t>3/31/2026</a:t>
             </a:fld>
             <a:endParaRPr lang="en-US"/>
           </a:p>
@@ -1029,7 +1029,7 @@
           <a:p>
             <a:fld id="{49B836C9-039A-46E3-8B8C-694019AC96F9}" type="datetimeFigureOut">
               <a:rPr lang="en-US" smtClean="0"/>
-              <a:t>3/30/2026</a:t>
+              <a:t>3/31/2026</a:t>
             </a:fld>
             <a:endParaRPr lang="en-US"/>
           </a:p>
@@ -1249,7 +1249,7 @@
           <a:p>
             <a:fld id="{D7BAAD77-0952-4A0F-B406-0526A080BBE6}" type="datetimeFigureOut">
               <a:rPr lang="en-US" smtClean="0"/>
-              <a:t>3/30/2026</a:t>
+              <a:t>3/31/2026</a:t>
             </a:fld>
             <a:endParaRPr lang="en-US"/>
           </a:p>
@@ -1447,7 +1447,7 @@
           <a:p>
             <a:fld id="{D7BAAD77-0952-4A0F-B406-0526A080BBE6}" type="datetimeFigureOut">
               <a:rPr lang="en-US" smtClean="0"/>
-              <a:t>3/30/2026</a:t>
+              <a:t>3/31/2026</a:t>
             </a:fld>
             <a:endParaRPr lang="en-US"/>
           </a:p>
@@ -1722,7 +1722,7 @@
           <a:p>
             <a:fld id="{D7BAAD77-0952-4A0F-B406-0526A080BBE6}" type="datetimeFigureOut">
               <a:rPr lang="en-US" smtClean="0"/>
-              <a:t>3/30/2026</a:t>
+              <a:t>3/31/2026</a:t>
             </a:fld>
             <a:endParaRPr lang="en-US"/>
           </a:p>
@@ -1987,7 +1987,7 @@
           <a:p>
             <a:fld id="{D7BAAD77-0952-4A0F-B406-0526A080BBE6}" type="datetimeFigureOut">
               <a:rPr lang="en-US" smtClean="0"/>
-              <a:t>3/30/2026</a:t>
+              <a:t>3/31/2026</a:t>
             </a:fld>
             <a:endParaRPr lang="en-US"/>
           </a:p>
@@ -2399,7 +2399,7 @@
           <a:p>
             <a:fld id="{D7BAAD77-0952-4A0F-B406-0526A080BBE6}" type="datetimeFigureOut">
               <a:rPr lang="en-US" smtClean="0"/>
-              <a:t>3/30/2026</a:t>
+              <a:t>3/31/2026</a:t>
             </a:fld>
             <a:endParaRPr lang="en-US"/>
           </a:p>
@@ -2540,7 +2540,7 @@
           <a:p>
             <a:fld id="{D7BAAD77-0952-4A0F-B406-0526A080BBE6}" type="datetimeFigureOut">
               <a:rPr lang="en-US" smtClean="0"/>
-              <a:t>3/30/2026</a:t>
+              <a:t>3/31/2026</a:t>
             </a:fld>
             <a:endParaRPr lang="en-US"/>
           </a:p>
@@ -2653,7 +2653,7 @@
           <a:p>
             <a:fld id="{D7BAAD77-0952-4A0F-B406-0526A080BBE6}" type="datetimeFigureOut">
               <a:rPr lang="en-US" smtClean="0"/>
-              <a:t>3/30/2026</a:t>
+              <a:t>3/31/2026</a:t>
             </a:fld>
             <a:endParaRPr lang="en-US"/>
           </a:p>
@@ -2964,7 +2964,7 @@
           <a:p>
             <a:fld id="{D7BAAD77-0952-4A0F-B406-0526A080BBE6}" type="datetimeFigureOut">
               <a:rPr lang="en-US" smtClean="0"/>
-              <a:t>3/30/2026</a:t>
+              <a:t>3/31/2026</a:t>
             </a:fld>
             <a:endParaRPr lang="en-US"/>
           </a:p>
@@ -3162,7 +3162,7 @@
           <a:p>
             <a:fld id="{49B836C9-039A-46E3-8B8C-694019AC96F9}" type="datetimeFigureOut">
               <a:rPr lang="en-US" smtClean="0"/>
-              <a:t>3/30/2026</a:t>
+              <a:t>3/31/2026</a:t>
             </a:fld>
             <a:endParaRPr lang="en-US"/>
           </a:p>
@@ -3450,7 +3450,7 @@
           <a:p>
             <a:fld id="{D7BAAD77-0952-4A0F-B406-0526A080BBE6}" type="datetimeFigureOut">
               <a:rPr lang="en-US" smtClean="0"/>
-              <a:t>3/30/2026</a:t>
+              <a:t>3/31/2026</a:t>
             </a:fld>
             <a:endParaRPr lang="en-US"/>
           </a:p>
@@ -3648,7 +3648,7 @@
           <a:p>
             <a:fld id="{D7BAAD77-0952-4A0F-B406-0526A080BBE6}" type="datetimeFigureOut">
               <a:rPr lang="en-US" smtClean="0"/>
-              <a:t>3/30/2026</a:t>
+              <a:t>3/31/2026</a:t>
             </a:fld>
             <a:endParaRPr lang="en-US"/>
           </a:p>
@@ -3856,7 +3856,7 @@
           <a:p>
             <a:fld id="{D7BAAD77-0952-4A0F-B406-0526A080BBE6}" type="datetimeFigureOut">
               <a:rPr lang="en-US" smtClean="0"/>
-              <a:t>3/30/2026</a:t>
+              <a:t>3/31/2026</a:t>
             </a:fld>
             <a:endParaRPr lang="en-US"/>
           </a:p>
@@ -4131,7 +4131,7 @@
           <a:p>
             <a:fld id="{49B836C9-039A-46E3-8B8C-694019AC96F9}" type="datetimeFigureOut">
               <a:rPr lang="en-US" smtClean="0"/>
-              <a:t>3/30/2026</a:t>
+              <a:t>3/31/2026</a:t>
             </a:fld>
             <a:endParaRPr lang="en-US"/>
           </a:p>
@@ -4396,7 +4396,7 @@
           <a:p>
             <a:fld id="{49B836C9-039A-46E3-8B8C-694019AC96F9}" type="datetimeFigureOut">
               <a:rPr lang="en-US" smtClean="0"/>
-              <a:t>3/30/2026</a:t>
+              <a:t>3/31/2026</a:t>
             </a:fld>
             <a:endParaRPr lang="en-US"/>
           </a:p>
@@ -4808,7 +4808,7 @@
           <a:p>
             <a:fld id="{49B836C9-039A-46E3-8B8C-694019AC96F9}" type="datetimeFigureOut">
               <a:rPr lang="en-US" smtClean="0"/>
-              <a:t>3/30/2026</a:t>
+              <a:t>3/31/2026</a:t>
             </a:fld>
             <a:endParaRPr lang="en-US"/>
           </a:p>
@@ -4949,7 +4949,7 @@
           <a:p>
             <a:fld id="{49B836C9-039A-46E3-8B8C-694019AC96F9}" type="datetimeFigureOut">
               <a:rPr lang="en-US" smtClean="0"/>
-              <a:t>3/30/2026</a:t>
+              <a:t>3/31/2026</a:t>
             </a:fld>
             <a:endParaRPr lang="en-US"/>
           </a:p>
@@ -5062,7 +5062,7 @@
           <a:p>
             <a:fld id="{49B836C9-039A-46E3-8B8C-694019AC96F9}" type="datetimeFigureOut">
               <a:rPr lang="en-US" smtClean="0"/>
-              <a:t>3/30/2026</a:t>
+              <a:t>3/31/2026</a:t>
             </a:fld>
             <a:endParaRPr lang="en-US"/>
           </a:p>
@@ -5373,7 +5373,7 @@
           <a:p>
             <a:fld id="{49B836C9-039A-46E3-8B8C-694019AC96F9}" type="datetimeFigureOut">
               <a:rPr lang="en-US" smtClean="0"/>
-              <a:t>3/30/2026</a:t>
+              <a:t>3/31/2026</a:t>
             </a:fld>
             <a:endParaRPr lang="en-US"/>
           </a:p>
@@ -5661,7 +5661,7 @@
           <a:p>
             <a:fld id="{49B836C9-039A-46E3-8B8C-694019AC96F9}" type="datetimeFigureOut">
               <a:rPr lang="en-US" smtClean="0"/>
-              <a:t>3/30/2026</a:t>
+              <a:t>3/31/2026</a:t>
             </a:fld>
             <a:endParaRPr lang="en-US"/>
           </a:p>
@@ -5902,7 +5902,7 @@
           <a:p>
             <a:fld id="{49B836C9-039A-46E3-8B8C-694019AC96F9}" type="datetimeFigureOut">
               <a:rPr lang="en-US" smtClean="0"/>
-              <a:t>3/30/2026</a:t>
+              <a:t>3/31/2026</a:t>
             </a:fld>
             <a:endParaRPr lang="en-US"/>
           </a:p>
@@ -6473,7 +6473,7 @@
             <a:fld id="{D7BAAD77-0952-4A0F-B406-0526A080BBE6}" type="datetimeFigureOut">
               <a:rPr lang="en-US" smtClean="0"/>
               <a:pPr/>
-              <a:t>3/30/2026</a:t>
+              <a:t>3/31/2026</a:t>
             </a:fld>
             <a:endParaRPr lang="en-US"/>
           </a:p>
@@ -7248,8 +7248,11 @@
           <a:bodyPr/>
           <a:lstStyle/>
           <a:p>
-            <a:r>
-              <a:rPr sz="2800" b="0">
+            <a:pPr marL="0" indent="0">
+              <a:buNone/>
+            </a:pPr>
+            <a:r>
+              <a:rPr sz="2800" b="0" dirty="0">
                 <a:solidFill>
                   <a:srgbClr val="000000"/>
                 </a:solidFill>
@@ -7260,7 +7263,7 @@
           </a:p>
           <a:p>
             <a:r>
-              <a:rPr sz="2800" b="0">
+              <a:rPr sz="2800" b="0" dirty="0">
                 <a:solidFill>
                   <a:srgbClr val="000000"/>
                 </a:solidFill>
@@ -7271,7 +7274,7 @@
           </a:p>
           <a:p>
             <a:r>
-              <a:rPr sz="2800" b="0">
+              <a:rPr sz="2800" b="0" dirty="0">
                 <a:solidFill>
                   <a:srgbClr val="000000"/>
                 </a:solidFill>
@@ -7282,7 +7285,7 @@
           </a:p>
           <a:p>
             <a:r>
-              <a:rPr sz="2800" b="0">
+              <a:rPr sz="2800" b="0" dirty="0">
                 <a:solidFill>
                   <a:srgbClr val="000000"/>
                 </a:solidFill>
@@ -7293,7 +7296,7 @@
           </a:p>
           <a:p>
             <a:r>
-              <a:rPr sz="2800" b="0">
+              <a:rPr sz="2800" b="0" dirty="0">
                 <a:solidFill>
                   <a:srgbClr val="000000"/>
                 </a:solidFill>
@@ -7304,7 +7307,7 @@
           </a:p>
           <a:p>
             <a:r>
-              <a:rPr sz="2800" b="0">
+              <a:rPr sz="2800" b="0" dirty="0">
                 <a:solidFill>
                   <a:srgbClr val="000000"/>
                 </a:solidFill>
@@ -7330,8 +7333,11 @@
           <a:bodyPr/>
           <a:lstStyle/>
           <a:p>
-            <a:r>
-              <a:rPr sz="2800" b="0">
+            <a:pPr marL="0" indent="0">
+              <a:buNone/>
+            </a:pPr>
+            <a:r>
+              <a:rPr sz="2800" b="0" dirty="0">
                 <a:solidFill>
                   <a:srgbClr val="000000"/>
                 </a:solidFill>
@@ -7342,7 +7348,7 @@
           </a:p>
           <a:p>
             <a:r>
-              <a:rPr sz="2800" b="0">
+              <a:rPr sz="2800" b="0" dirty="0">
                 <a:solidFill>
                   <a:srgbClr val="000000"/>
                 </a:solidFill>
@@ -7353,7 +7359,7 @@
           </a:p>
           <a:p>
             <a:r>
-              <a:rPr sz="2800" b="0">
+              <a:rPr sz="2800" b="0" dirty="0">
                 <a:solidFill>
                   <a:srgbClr val="000000"/>
                 </a:solidFill>
@@ -7364,7 +7370,7 @@
           </a:p>
           <a:p>
             <a:r>
-              <a:rPr sz="2800" b="0">
+              <a:rPr sz="2800" b="0" dirty="0">
                 <a:solidFill>
                   <a:srgbClr val="000000"/>
                 </a:solidFill>
@@ -7375,7 +7381,7 @@
           </a:p>
           <a:p>
             <a:r>
-              <a:rPr sz="2800" b="0">
+              <a:rPr sz="2800" b="0" dirty="0">
                 <a:solidFill>
                   <a:srgbClr val="000000"/>
                 </a:solidFill>
@@ -7386,7 +7392,7 @@
           </a:p>
           <a:p>
             <a:r>
-              <a:rPr sz="2800" b="0">
+              <a:rPr sz="2800" b="0" dirty="0">
                 <a:solidFill>
                   <a:srgbClr val="000000"/>
                 </a:solidFill>
@@ -7871,8 +7877,11 @@
           <a:bodyPr/>
           <a:lstStyle/>
           <a:p>
-            <a:r>
-              <a:rPr sz="2800" b="0">
+            <a:pPr marL="0" indent="0">
+              <a:buNone/>
+            </a:pPr>
+            <a:r>
+              <a:rPr sz="2800" b="0" dirty="0">
                 <a:solidFill>
                   <a:srgbClr val="000000"/>
                 </a:solidFill>
@@ -7882,8 +7891,11 @@
             </a:r>
           </a:p>
           <a:p>
-            <a:r>
-              <a:rPr sz="2800" b="0">
+            <a:pPr marL="0" indent="0">
+              <a:buNone/>
+            </a:pPr>
+            <a:r>
+              <a:rPr sz="2800" b="0" dirty="0">
                 <a:solidFill>
                   <a:srgbClr val="000000"/>
                 </a:solidFill>
@@ -7893,8 +7905,11 @@
             </a:r>
           </a:p>
           <a:p>
-            <a:r>
-              <a:rPr sz="2800" b="0">
+            <a:pPr marL="0" indent="0">
+              <a:buNone/>
+            </a:pPr>
+            <a:r>
+              <a:rPr sz="2800" b="0" dirty="0">
                 <a:solidFill>
                   <a:srgbClr val="000000"/>
                 </a:solidFill>
@@ -7902,21 +7917,42 @@
               </a:rPr>
               <a:t>3. Fit a small tree to those mistakes</a:t>
             </a:r>
-          </a:p>
-          <a:p>
-            <a:r>
-              <a:rPr sz="2800" b="0">
+            <a:endParaRPr lang="en-US" sz="2800" b="0" dirty="0">
+              <a:solidFill>
+                <a:srgbClr val="000000"/>
+              </a:solidFill>
+              <a:latin typeface="Cambria"/>
+            </a:endParaRPr>
+          </a:p>
+          <a:p>
+            <a:pPr marL="0" indent="0">
+              <a:buNone/>
+            </a:pPr>
+            <a:r>
+              <a:rPr lang="en-US" dirty="0">
                 <a:solidFill>
                   <a:srgbClr val="000000"/>
                 </a:solidFill>
                 <a:latin typeface="Cambria"/>
               </a:rPr>
-              <a:t>4. Update the predictions a little</a:t>
-            </a:r>
-          </a:p>
-          <a:p>
-            <a:r>
-              <a:rPr sz="2800" b="0">
+              <a:t>4</a:t>
+            </a:r>
+            <a:r>
+              <a:rPr sz="2800" b="0" dirty="0">
+                <a:solidFill>
+                  <a:srgbClr val="000000"/>
+                </a:solidFill>
+                <a:latin typeface="Cambria"/>
+              </a:rPr>
+              <a:t>. Update the predictions a little</a:t>
+            </a:r>
+          </a:p>
+          <a:p>
+            <a:pPr marL="0" indent="0">
+              <a:buNone/>
+            </a:pPr>
+            <a:r>
+              <a:rPr sz="2800" b="0" dirty="0">
                 <a:solidFill>
                   <a:srgbClr val="000000"/>
                 </a:solidFill>

</xml_diff>